<commit_message>
Update to the midtest report slides
</commit_message>
<xml_diff>
--- a/project_reports/CapstoneMidterm.pptx
+++ b/project_reports/CapstoneMidterm.pptx
@@ -15558,31 +15558,43 @@
             </a:r>
           </a:p>
           <a:p>
-            <a:pPr lvl="1"/>
+            <a:pPr marL="800100" lvl="1" indent="-342900">
+              <a:buFont typeface="Arial" panose="020B0604020202020204" pitchFamily="34" charset="0"/>
+              <a:buChar char="•"/>
+            </a:pPr>
             <a:r>
               <a:rPr lang="en-US" sz="2000" dirty="0"/>
-              <a:t>• U.S. Census / ACS</a:t>
-            </a:r>
-            <a:br>
+              <a:t>U.S. Census / ACS</a:t>
+            </a:r>
+          </a:p>
+          <a:p>
+            <a:pPr marL="800100" lvl="1" indent="-342900">
+              <a:buFont typeface="Arial" panose="020B0604020202020204" pitchFamily="34" charset="0"/>
+              <a:buChar char="•"/>
+            </a:pPr>
+            <a:r>
               <a:rPr lang="en-US" sz="2000" dirty="0"/>
-            </a:br>
+              <a:t>NOAA Hurricane Data</a:t>
+            </a:r>
+          </a:p>
+          <a:p>
+            <a:pPr marL="800100" lvl="1" indent="-342900">
+              <a:buFont typeface="Arial" panose="020B0604020202020204" pitchFamily="34" charset="0"/>
+              <a:buChar char="•"/>
+            </a:pPr>
             <a:r>
               <a:rPr lang="en-US" sz="2000" dirty="0"/>
-              <a:t>• NOAA Hurricane Data</a:t>
-            </a:r>
-            <a:br>
+              <a:t>USGS Earthquake Data</a:t>
+            </a:r>
+          </a:p>
+          <a:p>
+            <a:pPr marL="800100" lvl="1" indent="-342900">
+              <a:buFont typeface="Arial" panose="020B0604020202020204" pitchFamily="34" charset="0"/>
+              <a:buChar char="•"/>
+            </a:pPr>
+            <a:r>
               <a:rPr lang="en-US" sz="2000" dirty="0"/>
-            </a:br>
-            <a:r>
-              <a:rPr lang="en-US" sz="2000" dirty="0"/>
-              <a:t>• USGS Earthquake Data</a:t>
-            </a:r>
-            <a:br>
-              <a:rPr lang="en-US" sz="2000" dirty="0"/>
-            </a:br>
-            <a:r>
-              <a:rPr lang="en-US" sz="2000" dirty="0"/>
-              <a:t>• Puerto Rico Crime Data</a:t>
+              <a:t>Police Dept. Puerto Rico-Crime Data</a:t>
             </a:r>
           </a:p>
           <a:p>
@@ -15598,50 +15610,56 @@
             </a:r>
           </a:p>
           <a:p>
-            <a:pPr lvl="1"/>
-            <a:r>
-              <a:rPr lang="en-US" sz="2000" dirty="0"/>
-              <a:t>• </a:t>
-            </a:r>
+            <a:pPr marL="800100" lvl="1" indent="-342900">
+              <a:buFont typeface="Arial" panose="020B0604020202020204" pitchFamily="34" charset="0"/>
+              <a:buChar char="•"/>
+            </a:pPr>
             <a:r>
               <a:rPr lang="en-US" sz="2000" dirty="0" err="1"/>
               <a:t>median_income</a:t>
             </a:r>
-            <a:br>
-              <a:rPr lang="en-US" sz="2000" dirty="0"/>
-            </a:br>
-            <a:r>
-              <a:rPr lang="en-US" sz="2000" dirty="0"/>
-              <a:t>• </a:t>
-            </a:r>
+            <a:endParaRPr lang="en-US" sz="2000" dirty="0"/>
+          </a:p>
+          <a:p>
+            <a:pPr marL="800100" lvl="1" indent="-342900">
+              <a:buFont typeface="Arial" panose="020B0604020202020204" pitchFamily="34" charset="0"/>
+              <a:buChar char="•"/>
+            </a:pPr>
             <a:r>
               <a:rPr lang="en-US" sz="2000" dirty="0" err="1"/>
               <a:t>vulnerability_index</a:t>
             </a:r>
-            <a:br>
-              <a:rPr lang="en-US" sz="2000" dirty="0"/>
-            </a:br>
-            <a:r>
-              <a:rPr lang="en-US" sz="2000" dirty="0"/>
-              <a:t>• </a:t>
-            </a:r>
+            <a:endParaRPr lang="en-US" sz="2000" dirty="0"/>
+          </a:p>
+          <a:p>
+            <a:pPr marL="800100" lvl="1" indent="-342900">
+              <a:buFont typeface="Arial" panose="020B0604020202020204" pitchFamily="34" charset="0"/>
+              <a:buChar char="•"/>
+            </a:pPr>
             <a:r>
               <a:rPr lang="en-US" sz="2000" dirty="0" err="1"/>
               <a:t>violent_crime_rate</a:t>
             </a:r>
-            <a:br>
+            <a:endParaRPr lang="en-US" sz="2000" dirty="0"/>
+          </a:p>
+          <a:p>
+            <a:pPr marL="800100" lvl="1" indent="-342900">
+              <a:buFont typeface="Arial" panose="020B0604020202020204" pitchFamily="34" charset="0"/>
+              <a:buChar char="•"/>
+            </a:pPr>
+            <a:r>
               <a:rPr lang="en-US" sz="2000" dirty="0"/>
-            </a:br>
+              <a:t>disaster intensity metrics</a:t>
+            </a:r>
+          </a:p>
+          <a:p>
+            <a:pPr marL="800100" lvl="1" indent="-342900">
+              <a:buFont typeface="Arial" panose="020B0604020202020204" pitchFamily="34" charset="0"/>
+              <a:buChar char="•"/>
+            </a:pPr>
             <a:r>
               <a:rPr lang="en-US" sz="2000" dirty="0"/>
-              <a:t>• disaster intensity metrics</a:t>
-            </a:r>
-            <a:br>
-              <a:rPr lang="en-US" sz="2000" dirty="0"/>
-            </a:br>
-            <a:r>
-              <a:rPr lang="en-US" sz="2000" dirty="0"/>
-              <a:t>• population change</a:t>
+              <a:t>population change</a:t>
             </a:r>
           </a:p>
           <a:p>
@@ -15674,8 +15692,8 @@
         </p:nvSpPr>
         <p:spPr>
           <a:xfrm>
-            <a:off x="5704888" y="1368962"/>
-            <a:ext cx="5439033" cy="3785652"/>
+            <a:off x="6314487" y="1477180"/>
+            <a:ext cx="6005332" cy="4401205"/>
           </a:xfrm>
           <a:prstGeom prst="rect">
             <a:avLst/>
@@ -15700,23 +15718,33 @@
             </a:r>
           </a:p>
           <a:p>
+            <a:pPr marL="800100" lvl="1" indent="-342900">
+              <a:buFont typeface="Arial" panose="020B0604020202020204" pitchFamily="34" charset="0"/>
+              <a:buChar char="•"/>
+            </a:pPr>
             <a:r>
               <a:rPr lang="en-US" sz="2000" dirty="0"/>
-              <a:t>• 78 municipalities</a:t>
-            </a:r>
-            <a:br>
+              <a:t>78 municipalities of Puerto Rico</a:t>
+            </a:r>
+          </a:p>
+          <a:p>
+            <a:pPr marL="800100" lvl="1" indent="-342900">
+              <a:buFont typeface="Arial" panose="020B0604020202020204" pitchFamily="34" charset="0"/>
+              <a:buChar char="•"/>
+            </a:pPr>
+            <a:r>
               <a:rPr lang="en-US" sz="2000" dirty="0"/>
-            </a:br>
+              <a:t>2010–2024 time period</a:t>
+            </a:r>
+          </a:p>
+          <a:p>
+            <a:pPr marL="800100" lvl="1" indent="-342900">
+              <a:buFont typeface="Arial" panose="020B0604020202020204" pitchFamily="34" charset="0"/>
+              <a:buChar char="•"/>
+            </a:pPr>
             <a:r>
               <a:rPr lang="en-US" sz="2000" dirty="0"/>
-              <a:t>• 2010–2024 time period</a:t>
-            </a:r>
-            <a:br>
-              <a:rPr lang="en-US" sz="2000" dirty="0"/>
-            </a:br>
-            <a:r>
-              <a:rPr lang="en-US" sz="2000" dirty="0"/>
-              <a:t>• Socioeconomic and environmental indicators</a:t>
+              <a:t>Socioeconomic and Vulnerability indicators</a:t>
             </a:r>
           </a:p>
           <a:p>
@@ -15735,9 +15763,33 @@
             </a:r>
           </a:p>
           <a:p>
+            <a:pPr marL="800100" lvl="1" indent="-342900">
+              <a:buFont typeface="Arial" panose="020B0604020202020204" pitchFamily="34" charset="0"/>
+              <a:buChar char="•"/>
+            </a:pPr>
+            <a:r>
+              <a:rPr lang="en-US" sz="2000" dirty="0"/>
+              <a:t>Overall Population Change </a:t>
+            </a:r>
+          </a:p>
+          <a:p>
+            <a:pPr marL="800100" lvl="1" indent="-342900">
+              <a:buFont typeface="Arial" panose="020B0604020202020204" pitchFamily="34" charset="0"/>
+              <a:buChar char="•"/>
+            </a:pPr>
             <a:r>
               <a:rPr lang="en-US" sz="2000" dirty="0"/>
               <a:t>Regional population change</a:t>
+            </a:r>
+          </a:p>
+          <a:p>
+            <a:pPr marL="800100" lvl="1" indent="-342900">
+              <a:buFont typeface="Arial" panose="020B0604020202020204" pitchFamily="34" charset="0"/>
+              <a:buChar char="•"/>
+            </a:pPr>
+            <a:r>
+              <a:rPr lang="en-US" sz="2000" dirty="0"/>
+              <a:t>Municipal Population Chance </a:t>
             </a:r>
           </a:p>
           <a:p>

</xml_diff>

<commit_message>
Update to the Midterm presentation
</commit_message>
<xml_diff>
--- a/project_reports/CapstoneMidterm.pptx
+++ b/project_reports/CapstoneMidterm.pptx
@@ -2173,6 +2173,15 @@
         <p:txBody>
           <a:bodyPr/>
           <a:lstStyle/>
+          <a:p>
+            <a:r>
+              <a:rPr lang="en-US" dirty="0"/>
+              <a:t>We evaluated several models using R² as the main performance metric. While all models produced negative R² scores—indicating the prediction task is highly challenging—the Lasso regression performed best among the tested methods. This suggests that feature selection improves predictive performance and that the relationship between socioeconomic variables and municipal population change is complex and noisy.</a:t>
+            </a:r>
+          </a:p>
+          <a:p>
+            <a:endParaRPr lang="en-US" dirty="0"/>
+          </a:p>
           <a:p>
             <a:r>
               <a:rPr lang="en-US" dirty="0"/>
@@ -6527,8 +6536,8 @@
         </p:nvSpPr>
         <p:spPr>
           <a:xfrm>
-            <a:off x="612924" y="2333060"/>
-            <a:ext cx="11081771" cy="914397"/>
+            <a:off x="612924" y="2667357"/>
+            <a:ext cx="11081771" cy="590932"/>
           </a:xfrm>
         </p:spPr>
         <p:txBody>
@@ -6886,127 +6895,6 @@
       </p:sp>
       <p:sp>
         <p:nvSpPr>
-          <p:cNvPr id="11" name="TextBox 10">
-            <a:extLst>
-              <a:ext uri="{FF2B5EF4-FFF2-40B4-BE49-F238E27FC236}">
-                <a16:creationId xmlns:a16="http://schemas.microsoft.com/office/drawing/2014/main" id="{9000A18A-81F2-D747-573D-5B8A59153A06}"/>
-              </a:ext>
-            </a:extLst>
-          </p:cNvPr>
-          <p:cNvSpPr txBox="1"/>
-          <p:nvPr/>
-        </p:nvSpPr>
-        <p:spPr>
-          <a:xfrm>
-            <a:off x="139613" y="1368962"/>
-            <a:ext cx="11729764" cy="2800767"/>
-          </a:xfrm>
-          <a:prstGeom prst="rect">
-            <a:avLst/>
-          </a:prstGeom>
-          <a:noFill/>
-        </p:spPr>
-        <p:txBody>
-          <a:bodyPr wrap="square">
-            <a:spAutoFit/>
-          </a:bodyPr>
-          <a:lstStyle/>
-          <a:p>
-            <a:r>
-              <a:rPr lang="en-US" sz="1600" b="1" dirty="0"/>
-              <a:t>Preliminary model evaluation:</a:t>
-            </a:r>
-          </a:p>
-          <a:p>
-            <a:endParaRPr lang="en-US" sz="1600" i="1" dirty="0"/>
-          </a:p>
-          <a:p>
-            <a:r>
-              <a:rPr lang="en-US" sz="1600" b="1" dirty="0"/>
-              <a:t>6.      </a:t>
-            </a:r>
-            <a:r>
-              <a:rPr lang="en-US" sz="1600" b="1" dirty="0" err="1"/>
-              <a:t>SHapley</a:t>
-            </a:r>
-            <a:r>
-              <a:rPr lang="en-US" sz="1600" b="1" dirty="0"/>
-              <a:t> Additive </a:t>
-            </a:r>
-            <a:r>
-              <a:rPr lang="en-US" sz="1600" b="1" dirty="0" err="1"/>
-              <a:t>exPlanations</a:t>
-            </a:r>
-            <a:r>
-              <a:rPr lang="en-US" sz="1600" b="1" dirty="0"/>
-              <a:t>: </a:t>
-            </a:r>
-            <a:r>
-              <a:rPr lang="en-US" sz="1600" dirty="0"/>
-              <a:t>A method for interpreting machine learning models. It estimates </a:t>
-            </a:r>
-            <a:r>
-              <a:rPr lang="en-US" sz="1600" i="1" dirty="0"/>
-              <a:t>how much each feature contributes to a prediction. </a:t>
-            </a:r>
-            <a:r>
-              <a:rPr lang="en-US" sz="1600" dirty="0"/>
-              <a:t>SHAP helps answer “Why did the model make this prediction?”</a:t>
-            </a:r>
-            <a:endParaRPr lang="en-US" sz="1600" i="1" dirty="0"/>
-          </a:p>
-          <a:p>
-            <a:pPr marL="342900" indent="-342900">
-              <a:buFont typeface="+mj-lt"/>
-              <a:buAutoNum type="arabicPeriod"/>
-            </a:pPr>
-            <a:endParaRPr lang="en-US" sz="1600" dirty="0"/>
-          </a:p>
-          <a:p>
-            <a:pPr marL="342900" indent="-342900">
-              <a:buFont typeface="+mj-lt"/>
-              <a:buAutoNum type="arabicPeriod"/>
-            </a:pPr>
-            <a:endParaRPr lang="en-US" sz="1600" dirty="0"/>
-          </a:p>
-          <a:p>
-            <a:r>
-              <a:rPr lang="en-US" sz="1600" dirty="0"/>
-              <a:t>Summary</a:t>
-            </a:r>
-          </a:p>
-          <a:p>
-            <a:pPr marL="342900" indent="-342900">
-              <a:buFont typeface="+mj-lt"/>
-              <a:buAutoNum type="arabicPeriod"/>
-            </a:pPr>
-            <a:endParaRPr lang="en-US" sz="1600" dirty="0"/>
-          </a:p>
-          <a:p>
-            <a:pPr marL="342900" indent="-342900">
-              <a:buFont typeface="+mj-lt"/>
-              <a:buAutoNum type="arabicPeriod"/>
-            </a:pPr>
-            <a:endParaRPr lang="en-US" sz="1600" dirty="0"/>
-          </a:p>
-          <a:p>
-            <a:pPr marL="342900" indent="-342900">
-              <a:buFont typeface="+mj-lt"/>
-              <a:buAutoNum type="arabicPeriod"/>
-            </a:pPr>
-            <a:endParaRPr lang="en-US" sz="1600" dirty="0"/>
-          </a:p>
-          <a:p>
-            <a:pPr marL="457200" indent="-457200">
-              <a:buFont typeface="+mj-lt"/>
-              <a:buAutoNum type="arabicPeriod"/>
-            </a:pPr>
-            <a:endParaRPr lang="en-US" sz="1600" dirty="0"/>
-          </a:p>
-        </p:txBody>
-      </p:sp>
-      <p:sp>
-        <p:nvSpPr>
           <p:cNvPr id="6" name="Text 8">
             <a:extLst>
               <a:ext uri="{FF2B5EF4-FFF2-40B4-BE49-F238E27FC236}">
@@ -7069,14 +6957,15 @@
               </a:ext>
             </a:extLst>
           </a:blip>
+          <a:srcRect b="18873"/>
           <a:stretch>
             <a:fillRect/>
           </a:stretch>
         </p:blipFill>
         <p:spPr>
           <a:xfrm>
-            <a:off x="459357" y="3214225"/>
-            <a:ext cx="7772400" cy="2936443"/>
+            <a:off x="115228" y="1513246"/>
+            <a:ext cx="10204154" cy="3127582"/>
           </a:xfrm>
           <a:prstGeom prst="rect">
             <a:avLst/>
@@ -7243,8 +7132,8 @@
         </p:nvSpPr>
         <p:spPr>
           <a:xfrm>
-            <a:off x="139613" y="1368962"/>
-            <a:ext cx="11729764" cy="5016758"/>
+            <a:off x="139613" y="1309970"/>
+            <a:ext cx="11729764" cy="5078313"/>
           </a:xfrm>
           <a:prstGeom prst="rect">
             <a:avLst/>
@@ -7263,90 +7152,96 @@
             </a:r>
           </a:p>
           <a:p>
-            <a:endParaRPr lang="en-US" sz="2000" dirty="0"/>
-          </a:p>
-          <a:p>
-            <a:r>
-              <a:rPr lang="en-US" sz="2000" b="1" dirty="0"/>
+            <a:endParaRPr lang="en-US" dirty="0"/>
+          </a:p>
+          <a:p>
+            <a:r>
+              <a:rPr lang="en-US" b="1" dirty="0"/>
               <a:t>Headline metrics:</a:t>
             </a:r>
-            <a:endParaRPr lang="en-US" sz="2000" dirty="0"/>
-          </a:p>
-          <a:p>
-            <a:endParaRPr lang="en-US" sz="2000" dirty="0"/>
-          </a:p>
-          <a:p>
-            <a:endParaRPr lang="en-US" sz="2000" dirty="0"/>
-          </a:p>
-          <a:p>
-            <a:endParaRPr lang="en-US" sz="2000" dirty="0"/>
-          </a:p>
-          <a:p>
-            <a:endParaRPr lang="en-US" sz="2000" dirty="0"/>
-          </a:p>
-          <a:p>
-            <a:endParaRPr lang="en-US" sz="2000" dirty="0"/>
-          </a:p>
-          <a:p>
-            <a:endParaRPr lang="en-US" sz="2000" dirty="0"/>
-          </a:p>
-          <a:p>
-            <a:r>
-              <a:rPr lang="en-US" sz="2000" b="1" dirty="0"/>
+            <a:endParaRPr lang="en-US" dirty="0"/>
+          </a:p>
+          <a:p>
+            <a:endParaRPr lang="en-US" dirty="0"/>
+          </a:p>
+          <a:p>
+            <a:endParaRPr lang="en-US" dirty="0"/>
+          </a:p>
+          <a:p>
+            <a:endParaRPr lang="en-US" dirty="0"/>
+          </a:p>
+          <a:p>
+            <a:endParaRPr lang="en-US" dirty="0"/>
+          </a:p>
+          <a:p>
+            <a:endParaRPr lang="en-US" dirty="0"/>
+          </a:p>
+          <a:p>
+            <a:endParaRPr lang="en-US" dirty="0"/>
+          </a:p>
+          <a:p>
+            <a:endParaRPr lang="en-US" dirty="0"/>
+          </a:p>
+          <a:p>
+            <a:endParaRPr lang="en-US" dirty="0"/>
+          </a:p>
+          <a:p>
+            <a:r>
+              <a:rPr lang="en-US" b="1" dirty="0"/>
               <a:t>Observations:</a:t>
             </a:r>
           </a:p>
           <a:p>
             <a:pPr lvl="1"/>
             <a:r>
-              <a:rPr lang="en-US" sz="2000" dirty="0"/>
-              <a:t>• Nonlinear models outperform simple baselines</a:t>
+              <a:rPr lang="en-US" dirty="0"/>
+              <a:t>• While all models produced negative R² score, indicating the prediction task is highly challenging</a:t>
             </a:r>
             <a:br>
-              <a:rPr lang="en-US" sz="2000" dirty="0"/>
+              <a:rPr lang="en-US" dirty="0"/>
             </a:br>
             <a:r>
-              <a:rPr lang="en-US" sz="2000" dirty="0"/>
-              <a:t>• Lag features significantly improve predictive performance</a:t>
+              <a:rPr lang="en-US" dirty="0"/>
+              <a:t>• Features selection significantly improve predictive performance</a:t>
             </a:r>
             <a:br>
-              <a:rPr lang="en-US" sz="2000" dirty="0"/>
+              <a:rPr lang="en-US" dirty="0"/>
             </a:br>
             <a:r>
-              <a:rPr lang="en-US" sz="2000" dirty="0"/>
+              <a:rPr lang="en-US" dirty="0"/>
               <a:t>• </a:t>
             </a:r>
             <a:r>
-              <a:rPr lang="en-US" sz="2000" dirty="0">
+              <a:rPr lang="en-US" dirty="0">
                 <a:solidFill>
                   <a:srgbClr val="1F2430"/>
                 </a:solidFill>
               </a:rPr>
-              <a:t>The pipeline clearly produces forecasts, plots, and exported summaries.</a:t>
-            </a:r>
-            <a:endParaRPr lang="en-US" sz="2000" dirty="0"/>
+              <a:t>The pipeline clearly produces forecasts, plots, and exported summaries</a:t>
+            </a:r>
+            <a:endParaRPr lang="en-US" dirty="0"/>
           </a:p>
           <a:p>
             <a:pPr lvl="1"/>
-            <a:endParaRPr lang="en-US" sz="2000" dirty="0"/>
-          </a:p>
-          <a:p>
-            <a:r>
-              <a:rPr lang="en-US" sz="2000" b="1" dirty="0"/>
+            <a:endParaRPr lang="en-US" dirty="0"/>
+          </a:p>
+          <a:p>
+            <a:r>
+              <a:rPr lang="en-US" b="1" dirty="0"/>
               <a:t>Interpretation:</a:t>
             </a:r>
           </a:p>
           <a:p>
             <a:r>
-              <a:rPr lang="en-US" sz="2000" dirty="0"/>
+              <a:rPr lang="en-US" dirty="0"/>
               <a:t>Population migration dynamics appear to contain </a:t>
             </a:r>
             <a:r>
-              <a:rPr lang="en-US" sz="2000" b="1" dirty="0"/>
+              <a:rPr lang="en-US" b="1" dirty="0"/>
               <a:t>predictable structure</a:t>
             </a:r>
             <a:r>
-              <a:rPr lang="en-US" sz="2000" dirty="0"/>
+              <a:rPr lang="en-US" dirty="0"/>
               <a:t>.</a:t>
             </a:r>
           </a:p>
@@ -7422,7 +7317,7 @@
         </p:blipFill>
         <p:spPr>
           <a:xfrm>
-            <a:off x="644324" y="2319998"/>
+            <a:off x="644324" y="2231510"/>
             <a:ext cx="4680030" cy="1839170"/>
           </a:xfrm>
           <a:prstGeom prst="rect">
@@ -7430,6 +7325,84 @@
           </a:prstGeom>
         </p:spPr>
       </p:pic>
+      <p:sp>
+        <p:nvSpPr>
+          <p:cNvPr id="8" name="TextBox 7">
+            <a:extLst>
+              <a:ext uri="{FF2B5EF4-FFF2-40B4-BE49-F238E27FC236}">
+                <a16:creationId xmlns:a16="http://schemas.microsoft.com/office/drawing/2014/main" id="{1D7D5FF6-720D-178E-6160-6CD260F89087}"/>
+              </a:ext>
+            </a:extLst>
+          </p:cNvPr>
+          <p:cNvSpPr txBox="1"/>
+          <p:nvPr/>
+        </p:nvSpPr>
+        <p:spPr>
+          <a:xfrm>
+            <a:off x="7393131" y="2398318"/>
+            <a:ext cx="4218038" cy="1169551"/>
+          </a:xfrm>
+          <a:prstGeom prst="rect">
+            <a:avLst/>
+          </a:prstGeom>
+          <a:noFill/>
+        </p:spPr>
+        <p:txBody>
+          <a:bodyPr wrap="square">
+            <a:spAutoFit/>
+          </a:bodyPr>
+          <a:lstStyle/>
+          <a:p>
+            <a:pPr>
+              <a:buNone/>
+            </a:pPr>
+            <a:r>
+              <a:rPr lang="en-US" sz="1400" dirty="0"/>
+              <a:t>Important migration drivers may not be in the dataset:</a:t>
+            </a:r>
+          </a:p>
+          <a:p>
+            <a:pPr marL="285750" indent="-285750">
+              <a:buFont typeface="Arial" panose="020B0604020202020204" pitchFamily="34" charset="0"/>
+              <a:buChar char="•"/>
+            </a:pPr>
+            <a:r>
+              <a:rPr lang="en-US" sz="1400" dirty="0"/>
+              <a:t>Housing prices</a:t>
+            </a:r>
+          </a:p>
+          <a:p>
+            <a:pPr marL="285750" indent="-285750">
+              <a:buFont typeface="Arial" panose="020B0604020202020204" pitchFamily="34" charset="0"/>
+              <a:buChar char="•"/>
+            </a:pPr>
+            <a:r>
+              <a:rPr lang="en-US" sz="1400" dirty="0"/>
+              <a:t>School quality</a:t>
+            </a:r>
+          </a:p>
+          <a:p>
+            <a:pPr marL="285750" indent="-285750">
+              <a:buFont typeface="Arial" panose="020B0604020202020204" pitchFamily="34" charset="0"/>
+              <a:buChar char="•"/>
+            </a:pPr>
+            <a:r>
+              <a:rPr lang="en-US" sz="1400" dirty="0"/>
+              <a:t>Local  &amp; Federal policy</a:t>
+            </a:r>
+          </a:p>
+          <a:p>
+            <a:pPr marL="285750" indent="-285750">
+              <a:buFont typeface="Arial" panose="020B0604020202020204" pitchFamily="34" charset="0"/>
+              <a:buChar char="•"/>
+            </a:pPr>
+            <a:r>
+              <a:rPr lang="en-US" sz="1400" dirty="0"/>
+              <a:t>Work trends</a:t>
+            </a:r>
+          </a:p>
+        </p:txBody>
+      </p:sp>
     </p:spTree>
     <p:extLst>
       <p:ext uri="{BB962C8B-B14F-4D97-AF65-F5344CB8AC3E}">
@@ -7573,7 +7546,7 @@
                 <a:ea typeface="Aptos Display" pitchFamily="34" charset="-122"/>
                 <a:cs typeface="Aptos Display" pitchFamily="34" charset="-120"/>
               </a:rPr>
-              <a:t>Scenario Simulation &amp; Forecasting</a:t>
+              <a:t>Forecasting</a:t>
             </a:r>
             <a:endParaRPr lang="en-US" sz="3200" dirty="0">
               <a:solidFill>
@@ -7585,10 +7558,10 @@
       </p:sp>
       <p:pic>
         <p:nvPicPr>
-          <p:cNvPr id="3" name="Image 0" descr="/mnt/data/notebook_images/Phase3_cell8_0.png">
+          <p:cNvPr id="7" name="Image 2" descr="/mnt/data/notebook_images/Phase3_cell17_3.png">
             <a:extLst>
               <a:ext uri="{FF2B5EF4-FFF2-40B4-BE49-F238E27FC236}">
-                <a16:creationId xmlns:a16="http://schemas.microsoft.com/office/drawing/2014/main" id="{5DEBE0AC-652C-3E17-3C01-92244C295C4A}"/>
+                <a16:creationId xmlns:a16="http://schemas.microsoft.com/office/drawing/2014/main" id="{649755F0-469F-321D-7500-F1F490BB2E56}"/>
               </a:ext>
             </a:extLst>
           </p:cNvPr>
@@ -7605,68 +7578,8 @@
         </p:blipFill>
         <p:spPr>
           <a:xfrm>
-            <a:off x="370069" y="1386832"/>
-            <a:ext cx="2930600" cy="1451966"/>
-          </a:xfrm>
-          <a:prstGeom prst="rect">
-            <a:avLst/>
-          </a:prstGeom>
-        </p:spPr>
-      </p:pic>
-      <p:pic>
-        <p:nvPicPr>
-          <p:cNvPr id="6" name="Image 1" descr="/mnt/data/notebook_images/Phase3_cell10_1.png">
-            <a:extLst>
-              <a:ext uri="{FF2B5EF4-FFF2-40B4-BE49-F238E27FC236}">
-                <a16:creationId xmlns:a16="http://schemas.microsoft.com/office/drawing/2014/main" id="{1ECBFE71-39D3-DB34-D262-59A236B876BA}"/>
-              </a:ext>
-            </a:extLst>
-          </p:cNvPr>
-          <p:cNvPicPr>
-            <a:picLocks noChangeAspect="1"/>
-          </p:cNvPicPr>
-          <p:nvPr/>
-        </p:nvPicPr>
-        <p:blipFill>
-          <a:blip r:embed="rId3"/>
-          <a:stretch>
-            <a:fillRect/>
-          </a:stretch>
-        </p:blipFill>
-        <p:spPr>
-          <a:xfrm>
-            <a:off x="353569" y="3382056"/>
-            <a:ext cx="2933566" cy="1451967"/>
-          </a:xfrm>
-          <a:prstGeom prst="rect">
-            <a:avLst/>
-          </a:prstGeom>
-        </p:spPr>
-      </p:pic>
-      <p:pic>
-        <p:nvPicPr>
-          <p:cNvPr id="7" name="Image 2" descr="/mnt/data/notebook_images/Phase3_cell17_3.png">
-            <a:extLst>
-              <a:ext uri="{FF2B5EF4-FFF2-40B4-BE49-F238E27FC236}">
-                <a16:creationId xmlns:a16="http://schemas.microsoft.com/office/drawing/2014/main" id="{649755F0-469F-321D-7500-F1F490BB2E56}"/>
-              </a:ext>
-            </a:extLst>
-          </p:cNvPr>
-          <p:cNvPicPr>
-            <a:picLocks noChangeAspect="1"/>
-          </p:cNvPicPr>
-          <p:nvPr/>
-        </p:nvPicPr>
-        <p:blipFill>
-          <a:blip r:embed="rId4"/>
-          <a:stretch>
-            <a:fillRect/>
-          </a:stretch>
-        </p:blipFill>
-        <p:spPr>
-          <a:xfrm>
-            <a:off x="3717088" y="3471556"/>
-            <a:ext cx="2745717" cy="1362467"/>
+            <a:off x="7006107" y="2375331"/>
+            <a:ext cx="4246819" cy="2107337"/>
           </a:xfrm>
           <a:prstGeom prst="rect">
             <a:avLst/>
@@ -7710,22 +7623,7 @@
                   <a:srgbClr val="1F2430"/>
                 </a:solidFill>
               </a:rPr>
-              <a:t>Sensitivity sweeps show how predictions respond to wind and seismic intensity.</a:t>
-            </a:r>
-            <a:endParaRPr lang="en-US" sz="1600" dirty="0"/>
-          </a:p>
-          <a:p>
-            <a:pPr marL="177800" indent="-177800">
-              <a:buSzPct val="100000"/>
-              <a:buChar char="•"/>
-            </a:pPr>
-            <a:r>
-              <a:rPr lang="en-US" sz="1600" dirty="0">
-                <a:solidFill>
-                  <a:srgbClr val="1F2430"/>
-                </a:solidFill>
-              </a:rPr>
-              <a:t>Forecast exports translate the model into decision-support outputs.</a:t>
+              <a:t>Forecast exports translate the model into decision-support outputs</a:t>
             </a:r>
             <a:endParaRPr lang="en-US" sz="1600" dirty="0"/>
           </a:p>
@@ -7848,7 +7746,7 @@
           <p:nvPr/>
         </p:nvPicPr>
         <p:blipFill>
-          <a:blip r:embed="rId5"/>
+          <a:blip r:embed="rId3"/>
           <a:srcRect t="25426" r="19188" b="34295"/>
           <a:stretch>
             <a:fillRect/>
@@ -7856,7 +7754,7 @@
         </p:blipFill>
         <p:spPr>
           <a:xfrm>
-            <a:off x="4725000" y="1246297"/>
+            <a:off x="113671" y="1905058"/>
             <a:ext cx="5790600" cy="2107337"/>
           </a:xfrm>
           <a:prstGeom prst="rect">
@@ -12357,16 +12255,16 @@
               <a:t>Puerto Rico has experienced </a:t>
             </a:r>
             <a:r>
-              <a:rPr lang="en-US" sz="1600" b="1" dirty="0">
+              <a:rPr lang="en-US" sz="1600" i="1" dirty="0">
                 <a:latin typeface="Merriweather" pitchFamily="2" charset="77"/>
               </a:rPr>
-              <a:t>significant population decline and regional vulnerability</a:t>
+              <a:t>significant population decline and regional vulnerability </a:t>
             </a:r>
             <a:r>
               <a:rPr lang="en-US" sz="1600" dirty="0">
                 <a:latin typeface="Merriweather" pitchFamily="2" charset="77"/>
               </a:rPr>
-              <a:t> driven by economic conditions, disasters, and social factors</a:t>
+              <a:t>driven by economic conditions, natural disasters, and social factors</a:t>
             </a:r>
           </a:p>
           <a:p>
@@ -12402,16 +12300,22 @@
               <a:t>Develop a </a:t>
             </a:r>
             <a:r>
-              <a:rPr lang="en-US" sz="1600" b="1" dirty="0">
+              <a:rPr lang="en-US" sz="1600" b="1" i="1" dirty="0">
                 <a:latin typeface="Merriweather" pitchFamily="2" charset="77"/>
               </a:rPr>
-              <a:t>data-driven machine learning framework</a:t>
+              <a:t>data-driven framework</a:t>
+            </a:r>
+            <a:r>
+              <a:rPr lang="en-US" sz="1600" i="1" dirty="0">
+                <a:latin typeface="Merriweather" pitchFamily="2" charset="77"/>
+              </a:rPr>
+              <a:t> </a:t>
             </a:r>
             <a:r>
               <a:rPr lang="en-US" sz="1600" dirty="0">
                 <a:latin typeface="Merriweather" pitchFamily="2" charset="77"/>
               </a:rPr>
-              <a:t> to:</a:t>
+              <a:t>to:</a:t>
             </a:r>
           </a:p>
           <a:p>
@@ -12426,13 +12330,7 @@
               <a:rPr lang="en-US" sz="1600" dirty="0">
                 <a:latin typeface="Merriweather" pitchFamily="2" charset="77"/>
               </a:rPr>
-              <a:t>Model </a:t>
-            </a:r>
-            <a:r>
-              <a:rPr lang="en-US" sz="1600" b="1" dirty="0">
-                <a:latin typeface="Merriweather" pitchFamily="2" charset="77"/>
-              </a:rPr>
-              <a:t>municipal population change</a:t>
+              <a:t>Model municipal and regional population change</a:t>
             </a:r>
           </a:p>
           <a:p>
@@ -12447,13 +12345,7 @@
               <a:rPr lang="en-US" sz="1600" dirty="0">
                 <a:latin typeface="Merriweather" pitchFamily="2" charset="77"/>
               </a:rPr>
-              <a:t>Identify </a:t>
-            </a:r>
-            <a:r>
-              <a:rPr lang="en-US" sz="1600" b="1" dirty="0">
-                <a:latin typeface="Merriweather" pitchFamily="2" charset="77"/>
-              </a:rPr>
-              <a:t>drivers of demographic decline</a:t>
+              <a:t>Identify drivers of demographic decline</a:t>
             </a:r>
           </a:p>
           <a:p>
@@ -12468,13 +12360,7 @@
               <a:rPr lang="en-US" sz="1600" dirty="0">
                 <a:latin typeface="Merriweather" pitchFamily="2" charset="77"/>
               </a:rPr>
-              <a:t>Detect </a:t>
-            </a:r>
-            <a:r>
-              <a:rPr lang="en-US" sz="1600" b="1" dirty="0">
-                <a:latin typeface="Merriweather" pitchFamily="2" charset="77"/>
-              </a:rPr>
-              <a:t>structural municipal vulnerability patterns</a:t>
+              <a:t>Detect structural municipal vulnerability patterns</a:t>
             </a:r>
           </a:p>
           <a:p>
@@ -12489,13 +12375,7 @@
               <a:rPr lang="en-US" sz="1600" dirty="0">
                 <a:latin typeface="Merriweather" pitchFamily="2" charset="77"/>
               </a:rPr>
-              <a:t>Produce </a:t>
-            </a:r>
-            <a:r>
-              <a:rPr lang="en-US" sz="1600" b="1" dirty="0">
-                <a:latin typeface="Merriweather" pitchFamily="2" charset="77"/>
-              </a:rPr>
-              <a:t>population forecasts and typologies</a:t>
+              <a:t>Produce population forecasts and typologies</a:t>
             </a:r>
           </a:p>
           <a:p>
@@ -15615,10 +15495,9 @@
               <a:buChar char="•"/>
             </a:pPr>
             <a:r>
-              <a:rPr lang="en-US" sz="2000" dirty="0" err="1"/>
-              <a:t>median_income</a:t>
-            </a:r>
-            <a:endParaRPr lang="en-US" sz="2000" dirty="0"/>
+              <a:rPr lang="en-US" sz="2000" dirty="0"/>
+              <a:t>population changes over years</a:t>
+            </a:r>
           </a:p>
           <a:p>
             <a:pPr marL="800100" lvl="1" indent="-342900">
@@ -15626,10 +15505,9 @@
               <a:buChar char="•"/>
             </a:pPr>
             <a:r>
-              <a:rPr lang="en-US" sz="2000" dirty="0" err="1"/>
-              <a:t>vulnerability_index</a:t>
-            </a:r>
-            <a:endParaRPr lang="en-US" sz="2000" dirty="0"/>
+              <a:rPr lang="en-US" sz="2000" dirty="0"/>
+              <a:t>Median income</a:t>
+            </a:r>
           </a:p>
           <a:p>
             <a:pPr marL="800100" lvl="1" indent="-342900">
@@ -15637,10 +15515,9 @@
               <a:buChar char="•"/>
             </a:pPr>
             <a:r>
-              <a:rPr lang="en-US" sz="2000" dirty="0" err="1"/>
-              <a:t>violent_crime_rate</a:t>
-            </a:r>
-            <a:endParaRPr lang="en-US" sz="2000" dirty="0"/>
+              <a:rPr lang="en-US" sz="2000" dirty="0"/>
+              <a:t>Vulnerability index</a:t>
+            </a:r>
           </a:p>
           <a:p>
             <a:pPr marL="800100" lvl="1" indent="-342900">
@@ -15649,7 +15526,7 @@
             </a:pPr>
             <a:r>
               <a:rPr lang="en-US" sz="2000" dirty="0"/>
-              <a:t>disaster intensity metrics</a:t>
+              <a:t>Violent crime rates</a:t>
             </a:r>
           </a:p>
           <a:p>
@@ -15659,7 +15536,7 @@
             </a:pPr>
             <a:r>
               <a:rPr lang="en-US" sz="2000" dirty="0"/>
-              <a:t>population change</a:t>
+              <a:t>disaster intensity metrics</a:t>
             </a:r>
           </a:p>
           <a:p>
@@ -16018,7 +15895,7 @@
             </a:br>
             <a:r>
               <a:rPr lang="en-US" sz="2000" dirty="0"/>
-              <a:t>• Migration patterns vary strongly by economic conditions</a:t>
+              <a:t>• Migration patterns vary strongly by region</a:t>
             </a:r>
           </a:p>
           <a:p>
@@ -16034,7 +15911,7 @@
             </a:r>
             <a:r>
               <a:rPr lang="en-US" sz="2000" dirty="0"/>
-              <a:t>Population change distribution or municipality map.</a:t>
+              <a:t>Population change municipality map</a:t>
             </a:r>
           </a:p>
           <a:p>
@@ -16300,7 +16177,7 @@
             </a:pPr>
             <a:r>
               <a:rPr lang="en-US" sz="2000" dirty="0"/>
-              <a:t>• Municipalities exposed to stronger hurricanes show greater migration shocks</a:t>
+              <a:t>• Municipalities exposed to stronger hurricanes and earthquakes show greater migration shocks</a:t>
             </a:r>
             <a:br>
               <a:rPr lang="en-US" sz="2000" dirty="0"/>
@@ -16370,8 +16247,8 @@
         </p:blipFill>
         <p:spPr>
           <a:xfrm>
-            <a:off x="7672818" y="2351430"/>
-            <a:ext cx="3298372" cy="2190047"/>
+            <a:off x="7714885" y="2567636"/>
+            <a:ext cx="3033526" cy="2014195"/>
           </a:xfrm>
           <a:prstGeom prst="rect">
             <a:avLst/>
@@ -16400,7 +16277,7 @@
         </p:blipFill>
         <p:spPr>
           <a:xfrm>
-            <a:off x="7672818" y="4702631"/>
+            <a:off x="7672818" y="4722295"/>
             <a:ext cx="4422678" cy="1639681"/>
           </a:xfrm>
           <a:prstGeom prst="rect">

</xml_diff>